<commit_message>
Some main changes and arduino mcu code
</commit_message>
<xml_diff>
--- a/docs/Foodi.pptx
+++ b/docs/Foodi.pptx
@@ -3959,7 +3959,7 @@
                   <a:srgbClr val="1C1F24"/>
                 </a:solidFill>
               </a:rPr>
-              <a:t>Pairing: owner joins the CCM to the home Wi-Fi, pairs the feeder over</a:t>
+              <a:t>Setup: owner joins the CCM to the home Wi-Fi once via Arduino App Lab,</a:t>
             </a:r>
           </a:p>
           <a:p>
@@ -3974,7 +3974,7 @@
                   <a:srgbClr val="1C1F24"/>
                 </a:solidFill>
               </a:rPr>
-              <a:t>Bluetooth, and the feeder joins Wi-Fi for smooth video.</a:t>
+              <a:t>pairs the feeder over Bluetooth, and the feeder joins Wi-Fi for video.</a:t>
             </a:r>
           </a:p>
         </p:txBody>

</xml_diff>

<commit_message>
Video prototype: live phone camera with AI overlay, 7-segment scale reading, UNO Q constraint simulator
- VideoPipeline: MJPEG ingest (phone/IP Webcam, ESP32, file), YOLOX overlay,
  eating banner, auto-reconnect; /api/video serves live stream or clip fallback
- scale.py: seven-segment LCD decoder reads the kitchen scale through the
  camera; median voting, occlusion hold when the pet blocks the display;
  scale weight feeds dashboard telemetry and eating detection
- simulate_uno_q.py: pins the backend to N cores, measures RSS/CPU/detection
  rate of the whole process tree, writes docs/performance.md
  (measured: 190 MB RAM, 25% of one core, 12 detections/s)
- Dashboard picks live <img> vs clip <video> automatically
- YoloxDetector thread cap (FOODI_VIDEO_THREADS) for constrained runs
- 37 tests pass (18 new scale decoder tests)
</commit_message>
<xml_diff>
--- a/docs/Foodi.pptx
+++ b/docs/Foodi.pptx
@@ -4626,6 +4626,43 @@
                 </a:solidFill>
               </a:rPr>
               <a:t>•  Demo insight: intake 45% below the 14-day average for 2 days -&gt; alert</a:t>
+            </a:r>
+          </a:p>
+          <a:p>
+            <a:pPr>
+              <a:spcAft>
+                <a:spcPts val="800"/>
+              </a:spcAft>
+            </a:pPr>
+          </a:p>
+          <a:p>
+            <a:pPr>
+              <a:spcAft>
+                <a:spcPts val="800"/>
+              </a:spcAft>
+            </a:pPr>
+            <a:r>
+              <a:rPr sz="1800" b="0">
+                <a:solidFill>
+                  <a:srgbClr val="E8743B"/>
+                </a:solidFill>
+              </a:rPr>
+              <a:t>Fits the UNO Q (measured, pinned to 1 core):</a:t>
+            </a:r>
+          </a:p>
+          <a:p>
+            <a:pPr>
+              <a:spcAft>
+                <a:spcPts val="800"/>
+              </a:spcAft>
+            </a:pPr>
+            <a:r>
+              <a:rPr sz="1800" b="0">
+                <a:solidFill>
+                  <a:srgbClr val="E8743B"/>
+                </a:solidFill>
+              </a:rPr>
+              <a:t>•  190 MB RAM of 2 GB, 25% CPU, 12 detections/s (need 1-2)</a:t>
             </a:r>
           </a:p>
         </p:txBody>

</xml_diff>